<commit_message>
Vertical-center text inside callout boxes
User noticed that single-line callouts were sitting at the top of
their boxes instead of being vertically centered, which looked off
on slides like S3 (the bottom thesis-summary strip) where the box
height clearly exceeded the line height.

Fix is in callout_box(): set the inner textbox's vertical_anchor to
MIDDLE and shrink the inner padding (top/bottom margin from 0.15 in
to 0.05 in). The textbox also expands to use the full callout box
height so the centering math has the right reference frame.

Effect: every callout — whether one-line or two-line — now has its
text vertically centered inside the box. Multi-line callouts that
already filled the box look unchanged.

https://claude.ai/code/session_01KsoZVcMJ4zaC3YipGd4nvb
</commit_message>
<xml_diff>
--- a/Hyunho_Kook_Master_Defense.pptx
+++ b/Hyunho_Kook_Master_Defense.pptx
@@ -3790,16 +3790,16 @@
         </p:nvSpPr>
         <p:spPr>
           <a:xfrm>
-            <a:off x="777240" y="2331720"/>
-            <a:ext cx="10789920" cy="228600"/>
-          </a:xfrm>
-          <a:prstGeom prst="rect">
-            <a:avLst/>
-          </a:prstGeom>
-          <a:noFill/>
-        </p:spPr>
-        <p:txBody>
-          <a:bodyPr wrap="square">
+            <a:off x="777240" y="2240279"/>
+            <a:ext cx="10789920" cy="411480"/>
+          </a:xfrm>
+          <a:prstGeom prst="rect">
+            <a:avLst/>
+          </a:prstGeom>
+          <a:noFill/>
+        </p:spPr>
+        <p:txBody>
+          <a:bodyPr wrap="square" anchor="ctr">
             <a:spAutoFit/>
           </a:bodyPr>
           <a:lstStyle/>
@@ -4278,16 +4278,16 @@
         </p:nvSpPr>
         <p:spPr>
           <a:xfrm>
-            <a:off x="777240" y="6126480"/>
-            <a:ext cx="10789920" cy="91440"/>
-          </a:xfrm>
-          <a:prstGeom prst="rect">
-            <a:avLst/>
-          </a:prstGeom>
-          <a:noFill/>
-        </p:spPr>
-        <p:txBody>
-          <a:bodyPr wrap="square">
+            <a:off x="777240" y="6035040"/>
+            <a:ext cx="10789920" cy="274320"/>
+          </a:xfrm>
+          <a:prstGeom prst="rect">
+            <a:avLst/>
+          </a:prstGeom>
+          <a:noFill/>
+        </p:spPr>
+        <p:txBody>
+          <a:bodyPr wrap="square" anchor="ctr">
             <a:spAutoFit/>
           </a:bodyPr>
           <a:lstStyle/>
@@ -5962,16 +5962,16 @@
         </p:nvSpPr>
         <p:spPr>
           <a:xfrm>
-            <a:off x="777240" y="5989320"/>
-            <a:ext cx="10789920" cy="274320"/>
-          </a:xfrm>
-          <a:prstGeom prst="rect">
-            <a:avLst/>
-          </a:prstGeom>
-          <a:noFill/>
-        </p:spPr>
-        <p:txBody>
-          <a:bodyPr wrap="square">
+            <a:off x="777240" y="5897880"/>
+            <a:ext cx="10789920" cy="457200"/>
+          </a:xfrm>
+          <a:prstGeom prst="rect">
+            <a:avLst/>
+          </a:prstGeom>
+          <a:noFill/>
+        </p:spPr>
+        <p:txBody>
+          <a:bodyPr wrap="square" anchor="ctr">
             <a:spAutoFit/>
           </a:bodyPr>
           <a:lstStyle/>
@@ -6319,16 +6319,16 @@
         </p:nvSpPr>
         <p:spPr>
           <a:xfrm>
-            <a:off x="777240" y="2880360"/>
-            <a:ext cx="10789920" cy="365759"/>
-          </a:xfrm>
-          <a:prstGeom prst="rect">
-            <a:avLst/>
-          </a:prstGeom>
-          <a:noFill/>
-        </p:spPr>
-        <p:txBody>
-          <a:bodyPr wrap="square">
+            <a:off x="777240" y="2788920"/>
+            <a:ext cx="10789920" cy="548640"/>
+          </a:xfrm>
+          <a:prstGeom prst="rect">
+            <a:avLst/>
+          </a:prstGeom>
+          <a:noFill/>
+        </p:spPr>
+        <p:txBody>
+          <a:bodyPr wrap="square" anchor="ctr">
             <a:spAutoFit/>
           </a:bodyPr>
           <a:lstStyle/>
@@ -6480,16 +6480,16 @@
         </p:nvSpPr>
         <p:spPr>
           <a:xfrm>
-            <a:off x="777240" y="4206240"/>
-            <a:ext cx="10789920" cy="365759"/>
-          </a:xfrm>
-          <a:prstGeom prst="rect">
-            <a:avLst/>
-          </a:prstGeom>
-          <a:noFill/>
-        </p:spPr>
-        <p:txBody>
-          <a:bodyPr wrap="square">
+            <a:off x="777240" y="4114800"/>
+            <a:ext cx="10789920" cy="548640"/>
+          </a:xfrm>
+          <a:prstGeom prst="rect">
+            <a:avLst/>
+          </a:prstGeom>
+          <a:noFill/>
+        </p:spPr>
+        <p:txBody>
+          <a:bodyPr wrap="square" anchor="ctr">
             <a:spAutoFit/>
           </a:bodyPr>
           <a:lstStyle/>
@@ -6605,16 +6605,16 @@
         </p:nvSpPr>
         <p:spPr>
           <a:xfrm>
-            <a:off x="777240" y="4937760"/>
-            <a:ext cx="10789920" cy="365759"/>
-          </a:xfrm>
-          <a:prstGeom prst="rect">
-            <a:avLst/>
-          </a:prstGeom>
-          <a:noFill/>
-        </p:spPr>
-        <p:txBody>
-          <a:bodyPr wrap="square">
+            <a:off x="777240" y="4846320"/>
+            <a:ext cx="10789920" cy="548640"/>
+          </a:xfrm>
+          <a:prstGeom prst="rect">
+            <a:avLst/>
+          </a:prstGeom>
+          <a:noFill/>
+        </p:spPr>
+        <p:txBody>
+          <a:bodyPr wrap="square" anchor="ctr">
             <a:spAutoFit/>
           </a:bodyPr>
           <a:lstStyle/>
@@ -6730,16 +6730,16 @@
         </p:nvSpPr>
         <p:spPr>
           <a:xfrm>
-            <a:off x="777240" y="5806440"/>
-            <a:ext cx="10789920" cy="365759"/>
-          </a:xfrm>
-          <a:prstGeom prst="rect">
-            <a:avLst/>
-          </a:prstGeom>
-          <a:noFill/>
-        </p:spPr>
-        <p:txBody>
-          <a:bodyPr wrap="square">
+            <a:off x="777240" y="5715000"/>
+            <a:ext cx="10789920" cy="548640"/>
+          </a:xfrm>
+          <a:prstGeom prst="rect">
+            <a:avLst/>
+          </a:prstGeom>
+          <a:noFill/>
+        </p:spPr>
+        <p:txBody>
+          <a:bodyPr wrap="square" anchor="ctr">
             <a:spAutoFit/>
           </a:bodyPr>
           <a:lstStyle/>
@@ -9204,16 +9204,16 @@
         </p:nvSpPr>
         <p:spPr>
           <a:xfrm>
-            <a:off x="777240" y="6263640"/>
-            <a:ext cx="10789920" cy="91440"/>
-          </a:xfrm>
-          <a:prstGeom prst="rect">
-            <a:avLst/>
-          </a:prstGeom>
-          <a:noFill/>
-        </p:spPr>
-        <p:txBody>
-          <a:bodyPr wrap="square">
+            <a:off x="777240" y="6172200"/>
+            <a:ext cx="10789920" cy="274320"/>
+          </a:xfrm>
+          <a:prstGeom prst="rect">
+            <a:avLst/>
+          </a:prstGeom>
+          <a:noFill/>
+        </p:spPr>
+        <p:txBody>
+          <a:bodyPr wrap="square" anchor="ctr">
             <a:spAutoFit/>
           </a:bodyPr>
           <a:lstStyle/>
@@ -9769,16 +9769,16 @@
         </p:nvSpPr>
         <p:spPr>
           <a:xfrm>
-            <a:off x="777240" y="6217920"/>
-            <a:ext cx="10789920" cy="91440"/>
-          </a:xfrm>
-          <a:prstGeom prst="rect">
-            <a:avLst/>
-          </a:prstGeom>
-          <a:noFill/>
-        </p:spPr>
-        <p:txBody>
-          <a:bodyPr wrap="square">
+            <a:off x="777240" y="6126480"/>
+            <a:ext cx="10789920" cy="274320"/>
+          </a:xfrm>
+          <a:prstGeom prst="rect">
+            <a:avLst/>
+          </a:prstGeom>
+          <a:noFill/>
+        </p:spPr>
+        <p:txBody>
+          <a:bodyPr wrap="square" anchor="ctr">
             <a:spAutoFit/>
           </a:bodyPr>
           <a:lstStyle/>
@@ -10573,16 +10573,16 @@
         </p:nvSpPr>
         <p:spPr>
           <a:xfrm>
-            <a:off x="777240" y="6263640"/>
-            <a:ext cx="10789920" cy="91440"/>
-          </a:xfrm>
-          <a:prstGeom prst="rect">
-            <a:avLst/>
-          </a:prstGeom>
-          <a:noFill/>
-        </p:spPr>
-        <p:txBody>
-          <a:bodyPr wrap="square">
+            <a:off x="777240" y="6172200"/>
+            <a:ext cx="10789920" cy="274320"/>
+          </a:xfrm>
+          <a:prstGeom prst="rect">
+            <a:avLst/>
+          </a:prstGeom>
+          <a:noFill/>
+        </p:spPr>
+        <p:txBody>
+          <a:bodyPr wrap="square" anchor="ctr">
             <a:spAutoFit/>
           </a:bodyPr>
           <a:lstStyle/>
@@ -11305,16 +11305,16 @@
         </p:nvSpPr>
         <p:spPr>
           <a:xfrm>
-            <a:off x="777240" y="6126480"/>
-            <a:ext cx="10789920" cy="228600"/>
-          </a:xfrm>
-          <a:prstGeom prst="rect">
-            <a:avLst/>
-          </a:prstGeom>
-          <a:noFill/>
-        </p:spPr>
-        <p:txBody>
-          <a:bodyPr wrap="square">
+            <a:off x="777240" y="6035040"/>
+            <a:ext cx="10789920" cy="411480"/>
+          </a:xfrm>
+          <a:prstGeom prst="rect">
+            <a:avLst/>
+          </a:prstGeom>
+          <a:noFill/>
+        </p:spPr>
+        <p:txBody>
+          <a:bodyPr wrap="square" anchor="ctr">
             <a:spAutoFit/>
           </a:bodyPr>
           <a:lstStyle/>
@@ -12126,16 +12126,16 @@
         </p:nvSpPr>
         <p:spPr>
           <a:xfrm>
-            <a:off x="777240" y="5852160"/>
-            <a:ext cx="10789920" cy="411480"/>
-          </a:xfrm>
-          <a:prstGeom prst="rect">
-            <a:avLst/>
-          </a:prstGeom>
-          <a:noFill/>
-        </p:spPr>
-        <p:txBody>
-          <a:bodyPr wrap="square">
+            <a:off x="777240" y="5760720"/>
+            <a:ext cx="10789920" cy="594360"/>
+          </a:xfrm>
+          <a:prstGeom prst="rect">
+            <a:avLst/>
+          </a:prstGeom>
+          <a:noFill/>
+        </p:spPr>
+        <p:txBody>
+          <a:bodyPr wrap="square" anchor="ctr">
             <a:spAutoFit/>
           </a:bodyPr>
           <a:lstStyle/>
@@ -12411,16 +12411,16 @@
         </p:nvSpPr>
         <p:spPr>
           <a:xfrm>
-            <a:off x="777240" y="2331720"/>
-            <a:ext cx="10789920" cy="640080"/>
-          </a:xfrm>
-          <a:prstGeom prst="rect">
-            <a:avLst/>
-          </a:prstGeom>
-          <a:noFill/>
-        </p:spPr>
-        <p:txBody>
-          <a:bodyPr wrap="square">
+            <a:off x="777240" y="2240279"/>
+            <a:ext cx="10789920" cy="822960"/>
+          </a:xfrm>
+          <a:prstGeom prst="rect">
+            <a:avLst/>
+          </a:prstGeom>
+          <a:noFill/>
+        </p:spPr>
+        <p:txBody>
+          <a:bodyPr wrap="square" anchor="ctr">
             <a:spAutoFit/>
           </a:bodyPr>
           <a:lstStyle/>
@@ -14975,16 +14975,16 @@
         </p:nvSpPr>
         <p:spPr>
           <a:xfrm>
-            <a:off x="777240" y="5806440"/>
-            <a:ext cx="10789920" cy="137160"/>
-          </a:xfrm>
-          <a:prstGeom prst="rect">
-            <a:avLst/>
-          </a:prstGeom>
-          <a:noFill/>
-        </p:spPr>
-        <p:txBody>
-          <a:bodyPr wrap="square">
+            <a:off x="777240" y="5715000"/>
+            <a:ext cx="10789920" cy="320040"/>
+          </a:xfrm>
+          <a:prstGeom prst="rect">
+            <a:avLst/>
+          </a:prstGeom>
+          <a:noFill/>
+        </p:spPr>
+        <p:txBody>
+          <a:bodyPr wrap="square" anchor="ctr">
             <a:spAutoFit/>
           </a:bodyPr>
           <a:lstStyle/>
@@ -15412,16 +15412,16 @@
         </p:nvSpPr>
         <p:spPr>
           <a:xfrm>
-            <a:off x="777240" y="5623560"/>
-            <a:ext cx="5486400" cy="594359"/>
-          </a:xfrm>
-          <a:prstGeom prst="rect">
-            <a:avLst/>
-          </a:prstGeom>
-          <a:noFill/>
-        </p:spPr>
-        <p:txBody>
-          <a:bodyPr wrap="square">
+            <a:off x="777240" y="5532120"/>
+            <a:ext cx="5486400" cy="777240"/>
+          </a:xfrm>
+          <a:prstGeom prst="rect">
+            <a:avLst/>
+          </a:prstGeom>
+          <a:noFill/>
+        </p:spPr>
+        <p:txBody>
+          <a:bodyPr wrap="square" anchor="ctr">
             <a:spAutoFit/>
           </a:bodyPr>
           <a:lstStyle/>
@@ -16107,16 +16107,16 @@
         </p:nvSpPr>
         <p:spPr>
           <a:xfrm>
-            <a:off x="777240" y="5074920"/>
-            <a:ext cx="10789920" cy="1005839"/>
-          </a:xfrm>
-          <a:prstGeom prst="rect">
-            <a:avLst/>
-          </a:prstGeom>
-          <a:noFill/>
-        </p:spPr>
-        <p:txBody>
-          <a:bodyPr wrap="square">
+            <a:off x="777240" y="4983480"/>
+            <a:ext cx="10789920" cy="1188719"/>
+          </a:xfrm>
+          <a:prstGeom prst="rect">
+            <a:avLst/>
+          </a:prstGeom>
+          <a:noFill/>
+        </p:spPr>
+        <p:txBody>
+          <a:bodyPr wrap="square" anchor="ctr">
             <a:spAutoFit/>
           </a:bodyPr>
           <a:lstStyle/>
@@ -16448,16 +16448,16 @@
         </p:nvSpPr>
         <p:spPr>
           <a:xfrm>
-            <a:off x="777240" y="2423160"/>
-            <a:ext cx="6126480" cy="365759"/>
-          </a:xfrm>
-          <a:prstGeom prst="rect">
-            <a:avLst/>
-          </a:prstGeom>
-          <a:noFill/>
-        </p:spPr>
-        <p:txBody>
-          <a:bodyPr wrap="square">
+            <a:off x="777240" y="2331720"/>
+            <a:ext cx="6126480" cy="548640"/>
+          </a:xfrm>
+          <a:prstGeom prst="rect">
+            <a:avLst/>
+          </a:prstGeom>
+          <a:noFill/>
+        </p:spPr>
+        <p:txBody>
+          <a:bodyPr wrap="square" anchor="ctr">
             <a:spAutoFit/>
           </a:bodyPr>
           <a:lstStyle/>
@@ -16586,16 +16586,16 @@
         </p:nvSpPr>
         <p:spPr>
           <a:xfrm>
-            <a:off x="777240" y="3246120"/>
-            <a:ext cx="6126480" cy="1188720"/>
-          </a:xfrm>
-          <a:prstGeom prst="rect">
-            <a:avLst/>
-          </a:prstGeom>
-          <a:noFill/>
-        </p:spPr>
-        <p:txBody>
-          <a:bodyPr wrap="square">
+            <a:off x="777240" y="3154679"/>
+            <a:ext cx="6126480" cy="1371600"/>
+          </a:xfrm>
+          <a:prstGeom prst="rect">
+            <a:avLst/>
+          </a:prstGeom>
+          <a:noFill/>
+        </p:spPr>
+        <p:txBody>
+          <a:bodyPr wrap="square" anchor="ctr">
             <a:spAutoFit/>
           </a:bodyPr>
           <a:lstStyle/>
@@ -17168,16 +17168,16 @@
         </p:nvSpPr>
         <p:spPr>
           <a:xfrm>
-            <a:off x="777240" y="2834640"/>
-            <a:ext cx="5486400" cy="365759"/>
-          </a:xfrm>
-          <a:prstGeom prst="rect">
-            <a:avLst/>
-          </a:prstGeom>
-          <a:noFill/>
-        </p:spPr>
-        <p:txBody>
-          <a:bodyPr wrap="square">
+            <a:off x="777240" y="2743200"/>
+            <a:ext cx="5486400" cy="548640"/>
+          </a:xfrm>
+          <a:prstGeom prst="rect">
+            <a:avLst/>
+          </a:prstGeom>
+          <a:noFill/>
+        </p:spPr>
+        <p:txBody>
+          <a:bodyPr wrap="square" anchor="ctr">
             <a:spAutoFit/>
           </a:bodyPr>
           <a:lstStyle/>
@@ -17563,16 +17563,16 @@
         </p:nvSpPr>
         <p:spPr>
           <a:xfrm>
-            <a:off x="777240" y="5669280"/>
-            <a:ext cx="10789920" cy="548640"/>
-          </a:xfrm>
-          <a:prstGeom prst="rect">
-            <a:avLst/>
-          </a:prstGeom>
-          <a:noFill/>
-        </p:spPr>
-        <p:txBody>
-          <a:bodyPr wrap="square">
+            <a:off x="777240" y="5577840"/>
+            <a:ext cx="10789920" cy="731520"/>
+          </a:xfrm>
+          <a:prstGeom prst="rect">
+            <a:avLst/>
+          </a:prstGeom>
+          <a:noFill/>
+        </p:spPr>
+        <p:txBody>
+          <a:bodyPr wrap="square" anchor="ctr">
             <a:spAutoFit/>
           </a:bodyPr>
           <a:lstStyle/>
@@ -19409,16 +19409,16 @@
         </p:nvSpPr>
         <p:spPr>
           <a:xfrm>
-            <a:off x="777240" y="6217920"/>
-            <a:ext cx="10789920" cy="137160"/>
-          </a:xfrm>
-          <a:prstGeom prst="rect">
-            <a:avLst/>
-          </a:prstGeom>
-          <a:noFill/>
-        </p:spPr>
-        <p:txBody>
-          <a:bodyPr wrap="square">
+            <a:off x="777240" y="6126480"/>
+            <a:ext cx="10789920" cy="320040"/>
+          </a:xfrm>
+          <a:prstGeom prst="rect">
+            <a:avLst/>
+          </a:prstGeom>
+          <a:noFill/>
+        </p:spPr>
+        <p:txBody>
+          <a:bodyPr wrap="square" anchor="ctr">
             <a:spAutoFit/>
           </a:bodyPr>
           <a:lstStyle/>

</xml_diff>